<commit_message>
Added new project files and updated documentation
</commit_message>
<xml_diff>
--- a/docs/REVIEW 1.pptx
+++ b/docs/REVIEW 1.pptx
@@ -294,20 +294,12 @@
 </p:presentation>
 </file>
 
-<file path=ppt/revisionInfo.xml><?xml version="1.0" encoding="utf-8"?>
-<p1510:revInfo xmlns:a="http://schemas.openxmlformats.org/drawingml/2006/main" xmlns:r="http://schemas.openxmlformats.org/officeDocument/2006/relationships" xmlns:p1510="http://schemas.microsoft.com/office/powerpoint/2015/10/main">
-  <p1510:revLst>
-    <p1510:client id="{AF08591D-1878-4B8D-B985-39927D5BD9AF}" v="28" dt="2026-08-15T07:47:00.963"/>
-  </p1510:revLst>
-</p1510:revInfo>
-</file>
-
 <file path=ppt/changesInfos/changesInfo1.xml><?xml version="1.0" encoding="utf-8"?>
 <pc:chgInfo xmlns:a="http://schemas.openxmlformats.org/drawingml/2006/main" xmlns:r="http://schemas.openxmlformats.org/officeDocument/2006/relationships" xmlns:ac="http://schemas.microsoft.com/office/drawing/2013/main/command" xmlns:pc="http://schemas.microsoft.com/office/powerpoint/2013/main/command">
   <pc:docChgLst>
     <pc:chgData name="Agastya Singh" userId="657c7a2772a972de" providerId="LiveId" clId="{8BA6A108-D51D-4F8E-BFB2-19194DA7E541}"/>
     <pc:docChg chg="undo custSel addSld modSld sldOrd">
-      <pc:chgData name="Agastya Singh" userId="657c7a2772a972de" providerId="LiveId" clId="{8BA6A108-D51D-4F8E-BFB2-19194DA7E541}" dt="2026-08-15T07:48:30.674" v="164" actId="22"/>
+      <pc:chgData name="Agastya Singh" userId="657c7a2772a972de" providerId="LiveId" clId="{8BA6A108-D51D-4F8E-BFB2-19194DA7E541}" dt="2026-08-19T03:34:09.501" v="184" actId="20577"/>
       <pc:docMkLst>
         <pc:docMk/>
       </pc:docMkLst>
@@ -325,6 +317,21 @@
             <ac:picMk id="3" creationId="{92F29D3D-2D57-F3C0-638A-4C40832F2767}"/>
           </ac:picMkLst>
         </pc:picChg>
+      </pc:sldChg>
+      <pc:sldChg chg="modSp mod">
+        <pc:chgData name="Agastya Singh" userId="657c7a2772a972de" providerId="LiveId" clId="{8BA6A108-D51D-4F8E-BFB2-19194DA7E541}" dt="2026-08-19T03:34:09.501" v="184" actId="20577"/>
+        <pc:sldMkLst>
+          <pc:docMk/>
+          <pc:sldMk cId="0" sldId="271"/>
+        </pc:sldMkLst>
+        <pc:spChg chg="mod">
+          <ac:chgData name="Agastya Singh" userId="657c7a2772a972de" providerId="LiveId" clId="{8BA6A108-D51D-4F8E-BFB2-19194DA7E541}" dt="2026-08-19T03:34:09.501" v="184" actId="20577"/>
+          <ac:spMkLst>
+            <pc:docMk/>
+            <pc:sldMk cId="0" sldId="271"/>
+            <ac:spMk id="567" creationId="{00000000-0000-0000-0000-000000000000}"/>
+          </ac:spMkLst>
+        </pc:spChg>
       </pc:sldChg>
       <pc:sldChg chg="modSp mod ord">
         <pc:chgData name="Agastya Singh" userId="657c7a2772a972de" providerId="LiveId" clId="{8BA6A108-D51D-4F8E-BFB2-19194DA7E541}" dt="2026-08-15T07:46:25.437" v="146" actId="1076"/>
@@ -347,14 +354,6 @@
           <pc:docMk/>
           <pc:sldMk cId="2345987422" sldId="295"/>
         </pc:sldMkLst>
-        <pc:spChg chg="del">
-          <ac:chgData name="Agastya Singh" userId="657c7a2772a972de" providerId="LiveId" clId="{8BA6A108-D51D-4F8E-BFB2-19194DA7E541}" dt="2026-08-15T07:47:19.944" v="155" actId="478"/>
-          <ac:spMkLst>
-            <pc:docMk/>
-            <pc:sldMk cId="2345987422" sldId="295"/>
-            <ac:spMk id="2" creationId="{33698232-6B33-1B6F-40ED-7739CD9E29A0}"/>
-          </ac:spMkLst>
-        </pc:spChg>
         <pc:spChg chg="mod">
           <ac:chgData name="Agastya Singh" userId="657c7a2772a972de" providerId="LiveId" clId="{8BA6A108-D51D-4F8E-BFB2-19194DA7E541}" dt="2026-08-15T07:47:26.573" v="157" actId="1076"/>
           <ac:spMkLst>
@@ -377,14 +376,6 @@
             <pc:docMk/>
             <pc:sldMk cId="2345987422" sldId="295"/>
             <ac:spMk id="5" creationId="{769C4899-93E3-62B0-184B-7D893CAF4F17}"/>
-          </ac:spMkLst>
-        </pc:spChg>
-        <pc:spChg chg="add del mod">
-          <ac:chgData name="Agastya Singh" userId="657c7a2772a972de" providerId="LiveId" clId="{8BA6A108-D51D-4F8E-BFB2-19194DA7E541}" dt="2026-08-15T07:47:21.403" v="156" actId="478"/>
-          <ac:spMkLst>
-            <pc:docMk/>
-            <pc:sldMk cId="2345987422" sldId="295"/>
-            <ac:spMk id="8" creationId="{DD955D79-9D23-3232-88C8-39BA6D73D7BC}"/>
           </ac:spMkLst>
         </pc:spChg>
       </pc:sldChg>
@@ -440,14 +431,6 @@
             <ac:graphicFrameMk id="2" creationId="{B1B6CE0B-5091-4327-74BF-A944AFB2C754}"/>
           </ac:graphicFrameMkLst>
         </pc:graphicFrameChg>
-        <pc:graphicFrameChg chg="del">
-          <ac:chgData name="Agastya Singh" userId="657c7a2772a972de" providerId="LiveId" clId="{8BA6A108-D51D-4F8E-BFB2-19194DA7E541}" dt="2026-08-15T07:15:00.994" v="74" actId="478"/>
-          <ac:graphicFrameMkLst>
-            <pc:docMk/>
-            <pc:sldMk cId="172956888" sldId="299"/>
-            <ac:graphicFrameMk id="6" creationId="{E5AFDE30-059C-543A-D6B0-B305B2B3571C}"/>
-          </ac:graphicFrameMkLst>
-        </pc:graphicFrameChg>
         <pc:picChg chg="mod">
           <ac:chgData name="Agastya Singh" userId="657c7a2772a972de" providerId="LiveId" clId="{8BA6A108-D51D-4F8E-BFB2-19194DA7E541}" dt="2026-08-15T07:39:09.728" v="91" actId="1076"/>
           <ac:picMkLst>
@@ -463,14 +446,6 @@
           <pc:docMk/>
           <pc:sldMk cId="3612756410" sldId="300"/>
         </pc:sldMkLst>
-        <pc:graphicFrameChg chg="del">
-          <ac:chgData name="Agastya Singh" userId="657c7a2772a972de" providerId="LiveId" clId="{8BA6A108-D51D-4F8E-BFB2-19194DA7E541}" dt="2026-08-15T07:39:29.979" v="94" actId="478"/>
-          <ac:graphicFrameMkLst>
-            <pc:docMk/>
-            <pc:sldMk cId="3612756410" sldId="300"/>
-            <ac:graphicFrameMk id="2" creationId="{735F3C43-9072-553C-FC5B-BEB4B0857DAE}"/>
-          </ac:graphicFrameMkLst>
-        </pc:graphicFrameChg>
         <pc:graphicFrameChg chg="add mod modGraphic">
           <ac:chgData name="Agastya Singh" userId="657c7a2772a972de" providerId="LiveId" clId="{8BA6A108-D51D-4F8E-BFB2-19194DA7E541}" dt="2026-08-15T07:40:34.082" v="102" actId="1076"/>
           <ac:graphicFrameMkLst>
@@ -509,86 +484,6 @@
           <pc:docMk/>
           <pc:sldMk cId="1751167747" sldId="302"/>
         </pc:sldMkLst>
-        <pc:spChg chg="del">
-          <ac:chgData name="Agastya Singh" userId="657c7a2772a972de" providerId="LiveId" clId="{8BA6A108-D51D-4F8E-BFB2-19194DA7E541}" dt="2026-08-15T07:43:27.035" v="131" actId="478"/>
-          <ac:spMkLst>
-            <pc:docMk/>
-            <pc:sldMk cId="1751167747" sldId="302"/>
-            <ac:spMk id="4" creationId="{0E7F3CEF-46EB-A3C9-03DE-1DAC7D5EBE08}"/>
-          </ac:spMkLst>
-        </pc:spChg>
-        <pc:spChg chg="del">
-          <ac:chgData name="Agastya Singh" userId="657c7a2772a972de" providerId="LiveId" clId="{8BA6A108-D51D-4F8E-BFB2-19194DA7E541}" dt="2026-08-15T07:43:27.035" v="131" actId="478"/>
-          <ac:spMkLst>
-            <pc:docMk/>
-            <pc:sldMk cId="1751167747" sldId="302"/>
-            <ac:spMk id="10" creationId="{3FCE85E7-95EF-C754-12FF-7672A8F7B249}"/>
-          </ac:spMkLst>
-        </pc:spChg>
-        <pc:spChg chg="del">
-          <ac:chgData name="Agastya Singh" userId="657c7a2772a972de" providerId="LiveId" clId="{8BA6A108-D51D-4F8E-BFB2-19194DA7E541}" dt="2026-08-15T07:43:27.035" v="131" actId="478"/>
-          <ac:spMkLst>
-            <pc:docMk/>
-            <pc:sldMk cId="1751167747" sldId="302"/>
-            <ac:spMk id="12" creationId="{1DCF828F-6E05-92A7-2A8E-E11666BC4950}"/>
-          </ac:spMkLst>
-        </pc:spChg>
-        <pc:spChg chg="del">
-          <ac:chgData name="Agastya Singh" userId="657c7a2772a972de" providerId="LiveId" clId="{8BA6A108-D51D-4F8E-BFB2-19194DA7E541}" dt="2026-08-15T07:43:27.035" v="131" actId="478"/>
-          <ac:spMkLst>
-            <pc:docMk/>
-            <pc:sldMk cId="1751167747" sldId="302"/>
-            <ac:spMk id="16" creationId="{313D22AC-3543-3099-3520-9E116535D545}"/>
-          </ac:spMkLst>
-        </pc:spChg>
-        <pc:spChg chg="del">
-          <ac:chgData name="Agastya Singh" userId="657c7a2772a972de" providerId="LiveId" clId="{8BA6A108-D51D-4F8E-BFB2-19194DA7E541}" dt="2026-08-15T07:43:27.035" v="131" actId="478"/>
-          <ac:spMkLst>
-            <pc:docMk/>
-            <pc:sldMk cId="1751167747" sldId="302"/>
-            <ac:spMk id="18" creationId="{C6C92FF9-41B8-9F09-3870-0C23E7FE0B40}"/>
-          </ac:spMkLst>
-        </pc:spChg>
-        <pc:spChg chg="del">
-          <ac:chgData name="Agastya Singh" userId="657c7a2772a972de" providerId="LiveId" clId="{8BA6A108-D51D-4F8E-BFB2-19194DA7E541}" dt="2026-08-15T07:43:27.035" v="131" actId="478"/>
-          <ac:spMkLst>
-            <pc:docMk/>
-            <pc:sldMk cId="1751167747" sldId="302"/>
-            <ac:spMk id="37" creationId="{33D03845-5C7A-D4A5-D43D-3D719E38BF09}"/>
-          </ac:spMkLst>
-        </pc:spChg>
-        <pc:spChg chg="del">
-          <ac:chgData name="Agastya Singh" userId="657c7a2772a972de" providerId="LiveId" clId="{8BA6A108-D51D-4F8E-BFB2-19194DA7E541}" dt="2026-08-15T07:43:27.035" v="131" actId="478"/>
-          <ac:spMkLst>
-            <pc:docMk/>
-            <pc:sldMk cId="1751167747" sldId="302"/>
-            <ac:spMk id="55" creationId="{9DB301BA-0364-F78C-F627-3C2003B15D7E}"/>
-          </ac:spMkLst>
-        </pc:spChg>
-        <pc:spChg chg="del">
-          <ac:chgData name="Agastya Singh" userId="657c7a2772a972de" providerId="LiveId" clId="{8BA6A108-D51D-4F8E-BFB2-19194DA7E541}" dt="2026-08-15T07:43:27.035" v="131" actId="478"/>
-          <ac:spMkLst>
-            <pc:docMk/>
-            <pc:sldMk cId="1751167747" sldId="302"/>
-            <ac:spMk id="62" creationId="{19EB036D-E37F-185B-BB10-2EDD9557BBC5}"/>
-          </ac:spMkLst>
-        </pc:spChg>
-        <pc:spChg chg="del">
-          <ac:chgData name="Agastya Singh" userId="657c7a2772a972de" providerId="LiveId" clId="{8BA6A108-D51D-4F8E-BFB2-19194DA7E541}" dt="2026-08-15T07:43:27.035" v="131" actId="478"/>
-          <ac:spMkLst>
-            <pc:docMk/>
-            <pc:sldMk cId="1751167747" sldId="302"/>
-            <ac:spMk id="922" creationId="{295AB660-2558-49F6-D5AF-41EE2D571C08}"/>
-          </ac:spMkLst>
-        </pc:spChg>
-        <pc:spChg chg="del">
-          <ac:chgData name="Agastya Singh" userId="657c7a2772a972de" providerId="LiveId" clId="{8BA6A108-D51D-4F8E-BFB2-19194DA7E541}" dt="2026-08-15T07:43:27.035" v="131" actId="478"/>
-          <ac:spMkLst>
-            <pc:docMk/>
-            <pc:sldMk cId="1751167747" sldId="302"/>
-            <ac:spMk id="928" creationId="{6E9CAD90-020C-3ABC-EAE4-00832B9A2CA6}"/>
-          </ac:spMkLst>
-        </pc:spChg>
         <pc:picChg chg="add mod">
           <ac:chgData name="Agastya Singh" userId="657c7a2772a972de" providerId="LiveId" clId="{8BA6A108-D51D-4F8E-BFB2-19194DA7E541}" dt="2026-08-15T07:43:48.961" v="140" actId="14100"/>
           <ac:picMkLst>
@@ -19915,7 +19810,7 @@
               <a:rPr lang="en-IN" sz="1400" dirty="0">
                 <a:sym typeface="Wingdings" panose="05000000000000000000" pitchFamily="2" charset="2"/>
               </a:rPr>
-              <a:t></a:t>
+              <a:t>To </a:t>
             </a:r>
             <a:r>
               <a:rPr lang="en-IN" sz="1400" dirty="0"/>
@@ -19928,7 +19823,7 @@
               <a:rPr lang="en-IN" sz="1400" dirty="0">
                 <a:sym typeface="Wingdings" panose="05000000000000000000" pitchFamily="2" charset="2"/>
               </a:rPr>
-              <a:t> </a:t>
+              <a:t> To </a:t>
             </a:r>
             <a:r>
               <a:rPr lang="en-IN" sz="1400" dirty="0"/>
@@ -19949,7 +19844,7 @@
               <a:rPr lang="en-IN" sz="1400" dirty="0">
                 <a:sym typeface="Wingdings" panose="05000000000000000000" pitchFamily="2" charset="2"/>
               </a:rPr>
-              <a:t> </a:t>
+              <a:t> To </a:t>
             </a:r>
             <a:r>
               <a:rPr lang="en-IN" sz="1400" dirty="0"/>
@@ -19962,7 +19857,7 @@
               <a:rPr lang="en-IN" sz="1400" dirty="0">
                 <a:sym typeface="Wingdings" panose="05000000000000000000" pitchFamily="2" charset="2"/>
               </a:rPr>
-              <a:t> </a:t>
+              <a:t> To </a:t>
             </a:r>
             <a:r>
               <a:rPr lang="en-IN" sz="1400" dirty="0"/>
@@ -19983,7 +19878,7 @@
               <a:rPr lang="en-IN" sz="1400" dirty="0">
                 <a:sym typeface="Wingdings" panose="05000000000000000000" pitchFamily="2" charset="2"/>
               </a:rPr>
-              <a:t> </a:t>
+              <a:t> To </a:t>
             </a:r>
             <a:r>
               <a:rPr lang="en-IN" sz="1400" dirty="0"/>
@@ -19993,14 +19888,18 @@
           <a:p>
             <a:pPr lvl="0" algn="l"/>
             <a:r>
-              <a:rPr lang="en-IN" sz="1400" dirty="0">
+              <a:rPr lang="en-IN" sz="1400">
                 <a:sym typeface="Wingdings" panose="05000000000000000000" pitchFamily="2" charset="2"/>
               </a:rPr>
-              <a:t> </a:t>
+              <a:t> To </a:t>
+            </a:r>
+            <a:r>
+              <a:rPr lang="en-IN" sz="1400"/>
+              <a:t>Build </a:t>
             </a:r>
             <a:r>
               <a:rPr lang="en-IN" sz="1400" dirty="0"/>
-              <a:t>Build a reliable and explainable document question-answering platform that minimizes hallucinations and improves user trust. </a:t>
+              <a:t>a reliable and explainable document question-answering platform that minimizes hallucinations and improves user trust. </a:t>
             </a:r>
           </a:p>
         </p:txBody>

</xml_diff>